<commit_message>
Switch the report and README to English, add value heatmaps to report and slides
- Report_Topic13_MultiDeliveryRobot.docx replaces the Vietnamese report
  (BaoCaoCuoiky_DeTai13_MultiDeliveryRobot.docx): full English translation,
  English-label figures, and the value heatmaps as Figures 7-8 in section 7.
- Slides: two new slides after the S4 policy slide (start values on the
  four maps, S4 values in four key phases).
- README.md translated to English; figures now point to figures_en/, and a
  short glossary explains the Vietnamese names left in the code.

Co-Authored-By: Claude Opus 5.5 <noreply@anthropic.com>
</commit_message>
<xml_diff>
--- a/Nguyen_Quang_Trungg-22011211/Slides_Topic13_MultiDeliveryRobot.pptx
+++ b/Nguyen_Quang_Trungg-22011211/Slides_Topic13_MultiDeliveryRobot.pptx
@@ -16,6 +16,8 @@
     <p:sldId id="261" r:id="rId6"/>
     <p:sldId id="269" r:id="rId19"/>
     <p:sldId id="263" r:id="rId8"/>
+    <p:sldId id="271" r:id="rId21"/>
+    <p:sldId id="270" r:id="rId20"/>
     <p:sldId id="264" r:id="rId9"/>
     <p:sldId id="265" r:id="rId10"/>
     <p:sldId id="266" r:id="rId11"/>
@@ -716,6 +718,180 @@
 </p:notes>
 </file>
 
+<file path=ppt/notesSlides/notesSlide14.xml><?xml version="1.0" encoding="utf-8"?>
+<p:notes xmlns:a="http://schemas.openxmlformats.org/drawingml/2006/main" xmlns:r="http://schemas.openxmlformats.org/officeDocument/2006/relationships" xmlns:p="http://schemas.openxmlformats.org/presentationml/2006/main">
+  <p:cSld>
+    <p:spTree>
+      <p:nvGrpSpPr>
+        <p:cNvPr id="1" name=""/>
+        <p:cNvGrpSpPr/>
+        <p:nvPr/>
+      </p:nvGrpSpPr>
+      <p:grpSpPr>
+        <a:xfrm>
+          <a:off x="0" y="0"/>
+          <a:ext cx="0" cy="0"/>
+          <a:chOff x="0" y="0"/>
+          <a:chExt cx="0" cy="0"/>
+        </a:xfrm>
+      </p:grpSpPr>
+      <p:sp>
+        <p:nvSpPr>
+          <p:cNvPr id="2" name="Slide Image Placeholder 1"/>
+          <p:cNvSpPr>
+            <a:spLocks noGrp="1" noRot="1" noChangeAspect="1"/>
+          </p:cNvSpPr>
+          <p:nvPr>
+            <p:ph type="sldImg"/>
+          </p:nvPr>
+        </p:nvSpPr>
+        <p:spPr/>
+      </p:sp>
+      <p:sp>
+        <p:nvSpPr>
+          <p:cNvPr id="3" name="Notes Placeholder 2"/>
+          <p:cNvSpPr>
+            <a:spLocks noGrp="1"/>
+          </p:cNvSpPr>
+          <p:nvPr>
+            <p:ph type="body" idx="1"/>
+          </p:nvPr>
+        </p:nvSpPr>
+        <p:spPr/>
+        <p:txBody>
+          <a:bodyPr/>
+          <a:lstStyle/>
+          <a:p>
+            <a:r>
+              <a:rPr lang="en-US" dirty="0"/>
+              <a:t>Each cell is coloured by the learned value V(s), the largest Q value of that state, when the robot starts there with every parcel waiting. Darker means a higher expected return. Values rise toward the first parcel to collect. The value at S is below the optimal return because the discount factor 0.99 makes a reward collected later worth less.</a:t>
+            </a:r>
+          </a:p>
+        </p:txBody>
+      </p:sp>
+      <p:sp>
+        <p:nvSpPr>
+          <p:cNvPr id="4" name="Slide Number Placeholder 3"/>
+          <p:cNvSpPr>
+            <a:spLocks noGrp="1"/>
+          </p:cNvSpPr>
+          <p:nvPr>
+            <p:ph type="sldNum" sz="quarter" idx="10"/>
+          </p:nvPr>
+        </p:nvSpPr>
+        <p:spPr/>
+        <p:txBody>
+          <a:bodyPr/>
+          <a:lstStyle/>
+          <a:p>
+            <a:fld id="{F7021451-1387-4CA6-816F-3879F97B5CBC}" type="slidenum">
+              <a:rPr lang="en-US"/>
+              <a:t>2</a:t>
+            </a:fld>
+            <a:endParaRPr lang="en-US"/>
+          </a:p>
+        </p:txBody>
+      </p:sp>
+    </p:spTree>
+    <p:extLst>
+      <p:ext uri="{BB962C8B-B14F-4D97-AF65-F5344CB8AC3E}">
+        <p14:creationId xmlns:p14="http://schemas.microsoft.com/office/powerpoint/2010/main" val="1024086991"/>
+      </p:ext>
+    </p:extLst>
+  </p:cSld>
+  <p:clrMapOvr>
+    <a:masterClrMapping/>
+  </p:clrMapOvr>
+</p:notes>
+</file>
+
+<file path=ppt/notesSlides/notesSlide15.xml><?xml version="1.0" encoding="utf-8"?>
+<p:notes xmlns:a="http://schemas.openxmlformats.org/drawingml/2006/main" xmlns:r="http://schemas.openxmlformats.org/officeDocument/2006/relationships" xmlns:p="http://schemas.openxmlformats.org/presentationml/2006/main">
+  <p:cSld>
+    <p:spTree>
+      <p:nvGrpSpPr>
+        <p:cNvPr id="1" name=""/>
+        <p:cNvGrpSpPr/>
+        <p:nvPr/>
+      </p:nvGrpSpPr>
+      <p:grpSpPr>
+        <a:xfrm>
+          <a:off x="0" y="0"/>
+          <a:ext cx="0" cy="0"/>
+          <a:chOff x="0" y="0"/>
+          <a:chExt cx="0" cy="0"/>
+        </a:xfrm>
+      </p:grpSpPr>
+      <p:sp>
+        <p:nvSpPr>
+          <p:cNvPr id="2" name="Slide Image Placeholder 1"/>
+          <p:cNvSpPr>
+            <a:spLocks noGrp="1" noRot="1" noChangeAspect="1"/>
+          </p:cNvSpPr>
+          <p:nvPr>
+            <p:ph type="sldImg"/>
+          </p:nvPr>
+        </p:nvSpPr>
+        <p:spPr/>
+      </p:sp>
+      <p:sp>
+        <p:nvSpPr>
+          <p:cNvPr id="3" name="Notes Placeholder 2"/>
+          <p:cNvSpPr>
+            <a:spLocks noGrp="1"/>
+          </p:cNvSpPr>
+          <p:nvPr>
+            <p:ph type="body" idx="1"/>
+          </p:nvPr>
+        </p:nvSpPr>
+        <p:spPr/>
+        <p:txBody>
+          <a:bodyPr/>
+          <a:lstStyle/>
+          <a:p>
+            <a:r>
+              <a:rPr lang="en-US" dirty="0"/>
+              <a:t>The same heatmap for four of the nine phases of the S4 route; the report shows all nine. Within a phase the colour grows toward the current target, which is why the greedy robot follows the darker cells. In phase 2 the robot carries D with 15 of its 22 steps used: from cells far from D's drop cell the deadline can no longer be met, so the value drops below zero. In phase 8 the robot carries A and B together, so almost every cell is dark.</a:t>
+            </a:r>
+          </a:p>
+        </p:txBody>
+      </p:sp>
+      <p:sp>
+        <p:nvSpPr>
+          <p:cNvPr id="4" name="Slide Number Placeholder 3"/>
+          <p:cNvSpPr>
+            <a:spLocks noGrp="1"/>
+          </p:cNvSpPr>
+          <p:nvPr>
+            <p:ph type="sldNum" sz="quarter" idx="10"/>
+          </p:nvPr>
+        </p:nvSpPr>
+        <p:spPr/>
+        <p:txBody>
+          <a:bodyPr/>
+          <a:lstStyle/>
+          <a:p>
+            <a:fld id="{F7021451-1387-4CA6-816F-3879F97B5CBC}" type="slidenum">
+              <a:rPr lang="en-US"/>
+              <a:t>2</a:t>
+            </a:fld>
+            <a:endParaRPr lang="en-US"/>
+          </a:p>
+        </p:txBody>
+      </p:sp>
+    </p:spTree>
+    <p:extLst>
+      <p:ext uri="{BB962C8B-B14F-4D97-AF65-F5344CB8AC3E}">
+        <p14:creationId xmlns:p14="http://schemas.microsoft.com/office/powerpoint/2010/main" val="1024086991"/>
+      </p:ext>
+    </p:extLst>
+  </p:cSld>
+  <p:clrMapOvr>
+    <a:masterClrMapping/>
+  </p:clrMapOvr>
+</p:notes>
+</file>
+
 <file path=ppt/notesSlides/notesSlide2.xml><?xml version="1.0" encoding="utf-8"?>
 <p:notes xmlns:a="http://schemas.openxmlformats.org/drawingml/2006/main" xmlns:r="http://schemas.openxmlformats.org/officeDocument/2006/relationships" xmlns:p="http://schemas.openxmlformats.org/presentationml/2006/main">
   <p:cSld>
@@ -6106,6 +6282,444 @@
             <a:fld id="{F7021451-1387-4CA6-816F-3879F97B5CBC}" type="slidenum">
               <a:rPr lang="en-US" b="0"/>
               <a:t>2</a:t>
+            </a:fld>
+            <a:endParaRPr lang="en-US"/>
+          </a:p>
+        </p:txBody>
+      </p:sp>
+    </p:spTree>
+  </p:cSld>
+  <p:clrMapOvr>
+    <a:masterClrMapping/>
+  </p:clrMapOvr>
+</p:sld>
+</file>
+
+<file path=ppt/slides/slide14.xml><?xml version="1.0" encoding="utf-8"?>
+<p:sld xmlns:a="http://schemas.openxmlformats.org/drawingml/2006/main" xmlns:r="http://schemas.openxmlformats.org/officeDocument/2006/relationships" xmlns:p="http://schemas.openxmlformats.org/presentationml/2006/main">
+  <p:cSld name="Slide 8">
+    <p:spTree>
+      <p:nvGrpSpPr>
+        <p:cNvPr id="1" name=""/>
+        <p:cNvGrpSpPr/>
+        <p:nvPr/>
+      </p:nvGrpSpPr>
+      <p:grpSpPr>
+        <a:xfrm>
+          <a:off x="0" y="0"/>
+          <a:ext cx="0" cy="0"/>
+          <a:chOff x="0" y="0"/>
+          <a:chExt cx="0" cy="0"/>
+        </a:xfrm>
+      </p:grpSpPr>
+      <p:sp>
+        <p:nvSpPr>
+          <p:cNvPr id="2" name="Text 0"/>
+          <p:cNvSpPr>
+            <a:spLocks noGrp="1"/>
+          </p:cNvSpPr>
+          <p:nvPr>
+            <p:ph type="title" idx="100" hasCustomPrompt="1"/>
+          </p:nvPr>
+        </p:nvSpPr>
+        <p:spPr>
+          <a:xfrm>
+            <a:off x="548640" y="320040"/>
+            <a:ext cx="11091672" cy="777240"/>
+          </a:xfrm>
+          <a:prstGeom prst="rect">
+            <a:avLst/>
+          </a:prstGeom>
+          <a:noFill/>
+          <a:ln/>
+        </p:spPr>
+        <p:txBody>
+          <a:bodyPr wrap="square" lIns="0" tIns="0" rIns="0" bIns="0" rtlCol="0" anchor="ctr"/>
+          <a:lstStyle/>
+          <a:p>
+            <a:pPr marL="0" indent="0" algn="l">
+              <a:buNone/>
+            </a:pPr>
+            <a:r>
+              <a:rPr lang="en-US" sz="3400" b="1" dirty="0">
+                <a:solidFill>
+                  <a:schemeClr val="tx1"/>
+                </a:solidFill>
+              </a:rPr>
+              <a:t>S4 values per phase: the deadline becomes a cliff</a:t>
+            </a:r>
+            <a:endParaRPr lang="en-US" sz="3400" dirty="0"/>
+          </a:p>
+        </p:txBody>
+      </p:sp>
+      <p:pic>
+        <p:nvPicPr>
+          <p:cNvPr id="3" name="value-s4" descr="value_S4_slide.png"/>
+          <p:cNvPicPr>
+            <a:picLocks noChangeAspect="1"/>
+          </p:cNvPicPr>
+          <p:nvPr/>
+        </p:nvPicPr>
+        <p:blipFill>
+          <a:blip r:embed="rId3"/>
+          <a:stretch>
+            <a:fillRect/>
+          </a:stretch>
+        </p:blipFill>
+        <p:spPr>
+          <a:xfrm>
+            <a:off x="548640" y="1188720"/>
+            <a:ext cx="4412347" cy="5029200"/>
+          </a:xfrm>
+          <a:prstGeom prst="rect">
+            <a:avLst/>
+          </a:prstGeom>
+        </p:spPr>
+      </p:pic>
+      <p:sp>
+        <p:nvSpPr>
+          <p:cNvPr id="4" name="value-points"/>
+          <p:cNvSpPr txBox="1"/>
+          <p:nvPr/>
+        </p:nvSpPr>
+        <p:spPr>
+          <a:xfrm>
+            <a:off x="6167934" y="1417320"/>
+            <a:ext cx="5472377" cy="3566160"/>
+          </a:xfrm>
+          <a:prstGeom prst="rect">
+            <a:avLst/>
+          </a:prstGeom>
+          <a:noFill/>
+          <a:ln/>
+        </p:spPr>
+        <p:txBody>
+          <a:bodyPr wrap="square" lIns="0" tIns="0" rIns="0" bIns="0" rtlCol="0" anchor="t"/>
+          <a:lstStyle/>
+          <a:p>
+            <a:pPr marL="342900" indent="-342900">
+              <a:spcAft>
+                <a:spcPts val="1000"/>
+              </a:spcAft>
+              <a:buSzPct val="100000"/>
+              <a:buFont typeface="+mj-lt"/>
+              <a:buAutoNum type="arabicPeriod"/>
+            </a:pPr>
+            <a:r>
+              <a:rPr lang="en-US" sz="1600" dirty="0">
+                <a:solidFill>
+                  <a:schemeClr val="tx2"/>
+                </a:solidFill>
+              </a:rPr>
+              <a:t>Four of the nine phases of the greedy route; the black line is the robot's path</a:t>
+            </a:r>
+            <a:endParaRPr lang="en-US" sz="1600" dirty="0"/>
+          </a:p>
+          <a:p>
+            <a:pPr marL="342900" indent="-342900">
+              <a:spcAft>
+                <a:spcPts val="1000"/>
+              </a:spcAft>
+              <a:buSzPct val="100000"/>
+              <a:buFont typeface="+mj-lt"/>
+              <a:buAutoNum type="arabicPeriod"/>
+            </a:pPr>
+            <a:r>
+              <a:rPr lang="en-US" sz="1600" dirty="0">
+                <a:solidFill>
+                  <a:schemeClr val="tx2"/>
+                </a:solidFill>
+              </a:rPr>
+              <a:t>Cells near the current target are darker, so the robot walks toward darker cells</a:t>
+            </a:r>
+            <a:endParaRPr lang="en-US" sz="1600" dirty="0"/>
+          </a:p>
+          <a:p>
+            <a:pPr marL="342900" indent="-342900">
+              <a:spcAft>
+                <a:spcPts val="1000"/>
+              </a:spcAft>
+              <a:buSzPct val="100000"/>
+              <a:buFont typeface="+mj-lt"/>
+              <a:buAutoNum type="arabicPeriod"/>
+            </a:pPr>
+            <a:r>
+              <a:rPr lang="en-US" sz="1600" dirty="0">
+                <a:solidFill>
+                  <a:schemeClr val="tx2"/>
+                </a:solidFill>
+              </a:rPr>
+              <a:t>Phase 2 (carrying D, τ = 15): cells far from D's drop fall to about −11, too late for the deadline</a:t>
+            </a:r>
+            <a:endParaRPr lang="en-US" sz="1600" dirty="0"/>
+          </a:p>
+          <a:p>
+            <a:pPr marL="342900" indent="-342900">
+              <a:spcAft>
+                <a:spcPts val="1000"/>
+              </a:spcAft>
+              <a:buSzPct val="100000"/>
+              <a:buFont typeface="+mj-lt"/>
+              <a:buAutoNum type="arabicPeriod"/>
+            </a:pPr>
+            <a:r>
+              <a:rPr lang="en-US" sz="1600" dirty="0">
+                <a:solidFill>
+                  <a:schemeClr val="tx2"/>
+                </a:solidFill>
+              </a:rPr>
+              <a:t>Phase 8 (A + B with the booster): the whole map is dark, two +20 rewards are close</a:t>
+            </a:r>
+            <a:endParaRPr lang="en-US" sz="1600" dirty="0"/>
+          </a:p>
+        </p:txBody>
+      </p:sp>
+      <p:sp>
+        <p:nvSpPr>
+          <p:cNvPr id="5" name="value-result"/>
+          <p:cNvSpPr txBox="1"/>
+          <p:nvPr/>
+        </p:nvSpPr>
+        <p:spPr>
+          <a:xfrm>
+            <a:off x="6167934" y="5120640"/>
+            <a:ext cx="5472377" cy="457200"/>
+          </a:xfrm>
+          <a:prstGeom prst="rect">
+            <a:avLst/>
+          </a:prstGeom>
+          <a:noFill/>
+          <a:ln/>
+        </p:spPr>
+        <p:txBody>
+          <a:bodyPr wrap="square" lIns="0" tIns="0" rIns="0" bIns="0" rtlCol="0" anchor="t"/>
+          <a:lstStyle/>
+          <a:p>
+            <a:pPr marL="0" indent="0">
+              <a:buNone/>
+            </a:pPr>
+            <a:r>
+              <a:rPr lang="en-US" sz="1800" b="1" dirty="0">
+                <a:solidFill>
+                  <a:schemeClr val="tx1"/>
+                </a:solidFill>
+              </a:rPr>
+              <a:t>Deadline and booster show up in the values</a:t>
+            </a:r>
+            <a:endParaRPr lang="en-US" sz="1800" dirty="0"/>
+          </a:p>
+        </p:txBody>
+      </p:sp>
+      <p:sp>
+        <p:nvSpPr>
+          <p:cNvPr id="25" name="Slide Number Placeholder 0"/>
+          <p:cNvSpPr>
+            <a:spLocks noGrp="1"/>
+          </p:cNvSpPr>
+          <p:nvPr>
+            <p:ph type="sldNum" sz="quarter" idx="4294967295"/>
+          </p:nvPr>
+        </p:nvSpPr>
+        <p:spPr>
+          <a:xfrm>
+            <a:off x="11091672" y="6355080"/>
+            <a:ext cx="548640" cy="274320"/>
+          </a:xfrm>
+          <a:prstGeom prst="rect">
+            <a:avLst/>
+          </a:prstGeom>
+          <a:extLst>
+            <a:ext uri="{C572A759-6A51-4108-AA02-DFA0A04FC94B}">
+              <ma14:wrappingTextBoxFlag xmlns:ma14="http://schemas.microsoft.com/office/mac/drawingml/2011/main" xmlns="" val="0"/>
+            </a:ext>
+          </a:extLst>
+        </p:spPr>
+        <p:txBody>
+          <a:bodyPr/>
+          <a:lstStyle>
+            <a:lvl1pPr>
+              <a:defRPr sz="1100">
+                <a:solidFill>
+                  <a:srgbClr val="737B89"/>
+                </a:solidFill>
+              </a:defRPr>
+            </a:lvl1pPr>
+          </a:lstStyle>
+          <a:p>
+            <a:pPr algn="r"/>
+            <a:fld id="{F7021451-1387-4CA6-816F-3879F97B5CBC}" type="slidenum">
+              <a:rPr lang="en-US" b="0"/>
+              <a:t>7</a:t>
+            </a:fld>
+            <a:endParaRPr lang="en-US"/>
+          </a:p>
+        </p:txBody>
+      </p:sp>
+    </p:spTree>
+  </p:cSld>
+  <p:clrMapOvr>
+    <a:masterClrMapping/>
+  </p:clrMapOvr>
+</p:sld>
+</file>
+
+<file path=ppt/slides/slide15.xml><?xml version="1.0" encoding="utf-8"?>
+<p:sld xmlns:a="http://schemas.openxmlformats.org/drawingml/2006/main" xmlns:r="http://schemas.openxmlformats.org/officeDocument/2006/relationships" xmlns:p="http://schemas.openxmlformats.org/presentationml/2006/main">
+  <p:cSld name="Slide 10">
+    <p:spTree>
+      <p:nvGrpSpPr>
+        <p:cNvPr id="1" name=""/>
+        <p:cNvGrpSpPr/>
+        <p:nvPr/>
+      </p:nvGrpSpPr>
+      <p:grpSpPr>
+        <a:xfrm>
+          <a:off x="0" y="0"/>
+          <a:ext cx="0" cy="0"/>
+          <a:chOff x="0" y="0"/>
+          <a:chExt cx="0" cy="0"/>
+        </a:xfrm>
+      </p:grpSpPr>
+      <p:sp>
+        <p:nvSpPr>
+          <p:cNvPr id="2" name="Text 0"/>
+          <p:cNvSpPr>
+            <a:spLocks noGrp="1"/>
+          </p:cNvSpPr>
+          <p:nvPr>
+            <p:ph type="title" idx="100" hasCustomPrompt="1"/>
+          </p:nvPr>
+        </p:nvSpPr>
+        <p:spPr>
+          <a:xfrm>
+            <a:off x="548640" y="320040"/>
+            <a:ext cx="11091672" cy="777240"/>
+          </a:xfrm>
+          <a:prstGeom prst="rect">
+            <a:avLst/>
+          </a:prstGeom>
+          <a:noFill/>
+          <a:ln/>
+        </p:spPr>
+        <p:txBody>
+          <a:bodyPr wrap="square" lIns="0" tIns="0" rIns="0" bIns="0" rtlCol="0" anchor="ctr"/>
+          <a:lstStyle/>
+          <a:p>
+            <a:pPr marL="0" indent="0" algn="l">
+              <a:buNone/>
+            </a:pPr>
+            <a:r>
+              <a:rPr lang="en-US" sz="3400" b="1" dirty="0">
+                <a:solidFill>
+                  <a:schemeClr val="tx1"/>
+                </a:solidFill>
+              </a:rPr>
+              <a:t>Learned values: darker cells promise a higher return</a:t>
+            </a:r>
+            <a:endParaRPr lang="en-US" sz="3400" dirty="0"/>
+          </a:p>
+        </p:txBody>
+      </p:sp>
+      <p:pic>
+        <p:nvPicPr>
+          <p:cNvPr id="3" name="value-start" descr="value_start.png"/>
+          <p:cNvPicPr>
+            <a:picLocks noChangeAspect="1"/>
+          </p:cNvPicPr>
+          <p:nvPr/>
+        </p:nvPicPr>
+        <p:blipFill>
+          <a:blip r:embed="rId3"/>
+          <a:stretch>
+            <a:fillRect/>
+          </a:stretch>
+        </p:blipFill>
+        <p:spPr>
+          <a:xfrm>
+            <a:off x="548640" y="1202130"/>
+            <a:ext cx="11091672" cy="4316579"/>
+          </a:xfrm>
+          <a:prstGeom prst="rect">
+            <a:avLst/>
+          </a:prstGeom>
+        </p:spPr>
+      </p:pic>
+      <p:sp>
+        <p:nvSpPr>
+          <p:cNvPr id="4" name="value-caption"/>
+          <p:cNvSpPr txBox="1"/>
+          <p:nvPr/>
+        </p:nvSpPr>
+        <p:spPr>
+          <a:xfrm>
+            <a:off x="548640" y="5623560"/>
+            <a:ext cx="11091672" cy="502920"/>
+          </a:xfrm>
+          <a:prstGeom prst="rect">
+            <a:avLst/>
+          </a:prstGeom>
+          <a:noFill/>
+          <a:ln/>
+        </p:spPr>
+        <p:txBody>
+          <a:bodyPr wrap="square" lIns="0" tIns="0" rIns="0" bIns="0" rtlCol="0" anchor="t"/>
+          <a:lstStyle/>
+          <a:p>
+            <a:pPr marL="0" indent="0">
+              <a:buNone/>
+            </a:pPr>
+            <a:r>
+              <a:rPr lang="en-US" sz="1700" dirty="0">
+                <a:solidFill>
+                  <a:schemeClr val="tx2"/>
+                </a:solidFill>
+              </a:rPr>
+              <a:t>V(s) = max Q(s, a) when the robot starts in a cell. V at S (13.7 / 17.8 / 8.6 / 2.5) is below the optimal return (18 / 24 / 16 / 13) because γ = 0.99 discounts late rewards.</a:t>
+            </a:r>
+            <a:endParaRPr lang="en-US" sz="1700" dirty="0"/>
+          </a:p>
+        </p:txBody>
+      </p:sp>
+      <p:sp>
+        <p:nvSpPr>
+          <p:cNvPr id="25" name="Slide Number Placeholder 0"/>
+          <p:cNvSpPr>
+            <a:spLocks noGrp="1"/>
+          </p:cNvSpPr>
+          <p:nvPr>
+            <p:ph type="sldNum" sz="quarter" idx="4294967295"/>
+          </p:nvPr>
+        </p:nvSpPr>
+        <p:spPr>
+          <a:xfrm>
+            <a:off x="11091672" y="6355080"/>
+            <a:ext cx="548640" cy="274320"/>
+          </a:xfrm>
+          <a:prstGeom prst="rect">
+            <a:avLst/>
+          </a:prstGeom>
+          <a:extLst>
+            <a:ext uri="{C572A759-6A51-4108-AA02-DFA0A04FC94B}">
+              <ma14:wrappingTextBoxFlag xmlns:ma14="http://schemas.microsoft.com/office/mac/drawingml/2011/main" xmlns="" val="0"/>
+            </a:ext>
+          </a:extLst>
+        </p:spPr>
+        <p:txBody>
+          <a:bodyPr/>
+          <a:lstStyle>
+            <a:lvl1pPr>
+              <a:defRPr sz="1100">
+                <a:solidFill>
+                  <a:srgbClr val="737B89"/>
+                </a:solidFill>
+              </a:defRPr>
+            </a:lvl1pPr>
+          </a:lstStyle>
+          <a:p>
+            <a:pPr algn="r"/>
+            <a:fld id="{F7021451-1387-4CA6-816F-3879F97B5CBC}" type="slidenum">
+              <a:rPr lang="en-US" b="0"/>
+              <a:t>9</a:t>
             </a:fld>
             <a:endParaRPr lang="en-US"/>
           </a:p>

</xml_diff>